<commit_message>
Prepare liver zonation portfolio release
</commit_message>
<xml_diff>
--- a/presentation/build/MASLD_zonation.pptx
+++ b/presentation/build/MASLD_zonation.pptx
@@ -529,7 +529,7 @@
           <a:p>
             <a:r>
               <a:rPr lang="en-US" dirty="0"/>
-              <a:t>Title slide. We are Roee Tekoah and Shira Gelbstein; this is our hackathon re-analysis of the single-nucleus RNA-seq in Gribben et al., Nature 2024, asking whether the evidence for progressive hepatocyte de-zonation in MASLD survives once tissue acquisition is controlled. One-line answer: in matched biopsies we find no detectable progressive de-zonation — a large collapse is excluded, subtle drift is not. We are not claiming zonation is 'preserved' in any positive sense, and we do not touch the paper's imaging/protein evidence.</a:t>
+              <a:t>Title slide. I am Roee Tekoah; this is our hackathon re-analysis of the single-nucleus RNA-seq in Gribben et al., Nature 2024, asking whether the evidence for progressive hepatocyte de-zonation in MASLD survives once tissue acquisition is controlled. One-line answer: in matched biopsies we find no detectable progressive de-zonation — a large collapse is excluded, subtle drift is not. We are not claiming zonation is 'preserved' in any positive sense, and we do not touch the paper's imaging/protein evidence.</a:t>
             </a:r>
             <a:endParaRPr lang="en-US" dirty="0"/>
           </a:p>
@@ -3526,14 +3526,6 @@
             <a:pPr algn="l" indent="0" marL="0">
               <a:buNone/>
             </a:pPr>
-            <a:r>
-              <a:rPr lang="en-US" sz="2000" dirty="0">
-                <a:solidFill>
-                  <a:srgbClr val="7E8F8B"/>
-                </a:solidFill>
-              </a:rPr>
-              <a:t>   ·   </a:t>
-            </a:r>
             <a:pPr algn="l" indent="0" marL="0">
               <a:buNone/>
             </a:pPr>
@@ -3543,7 +3535,7 @@
                   <a:srgbClr val="EDE7DB"/>
                 </a:solidFill>
               </a:rPr>
-              <a:t>Shira Gelbstein</a:t>
+              <a:t/>
             </a:r>
             <a:endParaRPr lang="en-US" sz="2000" dirty="0"/>
           </a:p>

</xml_diff>